<commit_message>
Hook deck: more room in the creator cards
</commit_message>
<xml_diff>
--- a/content/2026-10/hook-deck.pptx
+++ b/content/2026-10/hook-deck.pptx
@@ -143,7 +143,7 @@
   <p:extLst>
     <p:ext uri="{521415D9-36F7-43E2-AB2F-B90AF26B5E84}">
       <p14:sectionLst xmlns:p14="http://schemas.microsoft.com/office/powerpoint/2010/main">
-        <p14:section name="Why these hooks" id="{abc20f73-c87a-7b68-0663-468d86c91645}">
+        <p14:section name="Why these hooks" id="{9d671fd5-8da1-724d-af7e-e1110ea516cf}">
           <p14:sldIdLst>
             <p14:sldId id="256"/>
             <p14:sldId id="257"/>
@@ -160,7 +160,7 @@
             <p14:sldId id="268"/>
           </p14:sldIdLst>
         </p14:section>
-        <p14:section name="Day 1 · Wed Oct 1" id="{5362fd15-b2f9-5061-b428-b0cfab4a5c6e}">
+        <p14:section name="Day 1 · Wed Oct 1" id="{eb854209-b9d0-3734-e8c9-c5057a6effc3}">
           <p14:sldIdLst>
             <p14:sldId id="269"/>
             <p14:sldId id="270"/>
@@ -168,7 +168,7 @@
             <p14:sldId id="272"/>
           </p14:sldIdLst>
         </p14:section>
-        <p14:section name="Day 2 · Thu Oct 2" id="{14428510-d6c1-a314-7bd5-02a2125470fb}">
+        <p14:section name="Day 2 · Thu Oct 2" id="{051fa1cd-4cfc-629f-4680-4b870bd6b3a3}">
           <p14:sldIdLst>
             <p14:sldId id="273"/>
             <p14:sldId id="274"/>
@@ -176,7 +176,7 @@
             <p14:sldId id="276"/>
           </p14:sldIdLst>
         </p14:section>
-        <p14:section name="Day 3 · Fri Oct 3" id="{89bcf11e-0a96-3826-3271-2d729d56ded1}">
+        <p14:section name="Day 3 · Fri Oct 3" id="{4e610225-20fb-482b-949f-db408848d9bd}">
           <p14:sldIdLst>
             <p14:sldId id="277"/>
             <p14:sldId id="278"/>
@@ -184,7 +184,7 @@
             <p14:sldId id="280"/>
           </p14:sldIdLst>
         </p14:section>
-        <p14:section name="Day 4 · Sat Oct 4" id="{ec619ce9-2c0f-9719-55fb-648848a94643}">
+        <p14:section name="Day 4 · Sat Oct 4" id="{c4148b8b-c63c-b00e-a458-8d6d8540c6bd}">
           <p14:sldIdLst>
             <p14:sldId id="281"/>
             <p14:sldId id="282"/>
@@ -192,7 +192,7 @@
             <p14:sldId id="284"/>
           </p14:sldIdLst>
         </p14:section>
-        <p14:section name="Day 5 · Sun Oct 5" id="{2dd1b3b3-b575-f7cf-db7a-821d26a10b63}">
+        <p14:section name="Day 5 · Sun Oct 5" id="{898cdcc2-acf0-d6c6-d8c2-3d42732c0041}">
           <p14:sldIdLst>
             <p14:sldId id="285"/>
             <p14:sldId id="286"/>
@@ -200,7 +200,7 @@
             <p14:sldId id="288"/>
           </p14:sldIdLst>
         </p14:section>
-        <p14:section name="Before every take · spares" id="{cd68b800-be28-51b5-a3af-0d7914694a4f}">
+        <p14:section name="Before every take · spares" id="{4884e0d5-c7c3-0db6-3445-559417987cc6}">
           <p14:sldIdLst>
             <p14:sldId id="289"/>
             <p14:sldId id="290"/>
@@ -4997,7 +4997,7 @@
         <p:spPr>
           <a:xfrm>
             <a:off x="812800" y="1117600"/>
-            <a:ext cx="10566400" cy="589280"/>
+            <a:ext cx="10566400" cy="530860"/>
           </a:xfrm>
           <a:prstGeom prst="rect">
             <a:avLst/>
@@ -5016,7 +5016,7 @@
               <a:buNone/>
             </a:pPr>
             <a:r>
-              <a:rPr lang="en-US" sz="3600" spc="-216" kern="0" dirty="0">
+              <a:rPr lang="en-US" sz="3200" spc="-192" kern="0" dirty="0">
                 <a:solidFill>
                   <a:srgbClr val="0F0F0F"/>
                 </a:solidFill>
@@ -5033,7 +5033,7 @@
               <a:buNone/>
             </a:pPr>
             <a:r>
-              <a:rPr lang="en-US" sz="3600" i="1" spc="-216" kern="0" dirty="0">
+              <a:rPr lang="en-US" sz="3200" i="1" spc="-192" kern="0" dirty="0">
                 <a:solidFill>
                   <a:srgbClr val="FF0090"/>
                 </a:solidFill>
@@ -5050,7 +5050,7 @@
               <a:buNone/>
             </a:pPr>
             <a:r>
-              <a:rPr lang="en-US" sz="3600" spc="-216" kern="0" dirty="0">
+              <a:rPr lang="en-US" sz="3200" spc="-192" kern="0" dirty="0">
                 <a:solidFill>
                   <a:srgbClr val="0F0F0F"/>
                 </a:solidFill>
@@ -5060,7 +5060,7 @@
               </a:rPr>
               <a:t> do</a:t>
             </a:r>
-            <a:endParaRPr lang="en-US" sz="3600" dirty="0"/>
+            <a:endParaRPr lang="en-US" sz="3200" dirty="0"/>
           </a:p>
         </p:txBody>
       </p:sp>
@@ -5072,8 +5072,8 @@
         </p:nvSpPr>
         <p:spPr>
           <a:xfrm>
-            <a:off x="812800" y="1859280"/>
-            <a:ext cx="3420533" cy="4363720"/>
+            <a:off x="812800" y="1788160"/>
+            <a:ext cx="3420533" cy="4511040"/>
           </a:xfrm>
           <a:prstGeom prst="roundRect">
             <a:avLst>
@@ -5106,8 +5106,8 @@
         </p:nvSpPr>
         <p:spPr>
           <a:xfrm>
-            <a:off x="4385733" y="1859280"/>
-            <a:ext cx="3420533" cy="4363720"/>
+            <a:off x="4385733" y="1788160"/>
+            <a:ext cx="3420533" cy="4511040"/>
           </a:xfrm>
           <a:prstGeom prst="roundRect">
             <a:avLst>
@@ -5140,8 +5140,8 @@
         </p:nvSpPr>
         <p:spPr>
           <a:xfrm>
-            <a:off x="7958667" y="1859280"/>
-            <a:ext cx="3420533" cy="4363720"/>
+            <a:off x="7958667" y="1788160"/>
+            <a:ext cx="3420533" cy="4511040"/>
           </a:xfrm>
           <a:prstGeom prst="roundRect">
             <a:avLst>
@@ -5174,8 +5174,8 @@
         </p:nvSpPr>
         <p:spPr>
           <a:xfrm>
-            <a:off x="990600" y="2024380"/>
-            <a:ext cx="3064933" cy="4033520"/>
+            <a:off x="990600" y="1940560"/>
+            <a:ext cx="3064933" cy="4206240"/>
           </a:xfrm>
           <a:prstGeom prst="rect">
             <a:avLst/>
@@ -5197,7 +5197,7 @@
               <a:buNone/>
             </a:pPr>
             <a:r>
-              <a:rPr lang="en-US" sz="1700" spc="-100" kern="0" dirty="0">
+              <a:rPr lang="en-US" sz="1600" spc="-100" kern="0" dirty="0">
                 <a:solidFill>
                   <a:srgbClr val="0F0F0F"/>
                 </a:solidFill>
@@ -5207,7 +5207,7 @@
               </a:rPr>
               <a:t>Pull, build, act</a:t>
             </a:r>
-            <a:endParaRPr lang="en-US" sz="1700" dirty="0"/>
+            <a:endParaRPr lang="en-US" sz="1600" dirty="0"/>
           </a:p>
           <a:p>
             <a:pPr indent="0" marL="0">
@@ -5220,7 +5220,7 @@
               <a:buNone/>
             </a:pPr>
             <a:r>
-              <a:rPr lang="en-US" sz="1200" dirty="0">
+              <a:rPr lang="en-US" sz="1150" dirty="0">
                 <a:solidFill>
                   <a:srgbClr val="6F6F6F"/>
                 </a:solidFill>
@@ -5230,12 +5230,12 @@
               </a:rPr>
               <a:t>Abigail · six figures on mid-tier engagement</a:t>
             </a:r>
-            <a:endParaRPr lang="en-US" sz="1700" dirty="0"/>
+            <a:endParaRPr lang="en-US" sz="1600" dirty="0"/>
           </a:p>
           <a:p>
             <a:pPr indent="0" marL="0">
               <a:lnSpc>
-                <a:spcPct val="132000"/>
+                <a:spcPct val="130000"/>
               </a:lnSpc>
               <a:spcAft>
                 <a:spcPts val="1000"/>
@@ -5253,12 +5253,12 @@
               </a:rPr>
               <a:t>Each video does one job: pull (broad, for strangers), build (specific, for the people already here) or act (direct, for buyers). Doing all three at once is why a video lands nowhere. Plan by job, not by look.</a:t>
             </a:r>
-            <a:endParaRPr lang="en-US" sz="1700" dirty="0"/>
+            <a:endParaRPr lang="en-US" sz="1600" dirty="0"/>
           </a:p>
           <a:p>
             <a:pPr indent="0" marL="0">
               <a:lnSpc>
-                <a:spcPct val="125000"/>
+                <a:spcPct val="122000"/>
               </a:lnSpc>
               <a:spcAft>
                 <a:spcPts val="1000"/>
@@ -5266,7 +5266,7 @@
               <a:buNone/>
             </a:pPr>
             <a:r>
-              <a:rPr lang="en-US" sz="1300" i="1" spc="-40" kern="0" dirty="0">
+              <a:rPr lang="en-US" sz="1250" i="1" spc="-40" kern="0" dirty="0">
                 <a:solidFill>
                   <a:srgbClr val="313336"/>
                 </a:solidFill>
@@ -5276,12 +5276,12 @@
               </a:rPr>
               <a:t>“Each video doesn’t have to go viral. It just has to pull someone in, build trust, or make someone act.”</a:t>
             </a:r>
-            <a:endParaRPr lang="en-US" sz="1700" dirty="0"/>
+            <a:endParaRPr lang="en-US" sz="1600" dirty="0"/>
           </a:p>
           <a:p>
             <a:pPr indent="0" marL="0">
               <a:lnSpc>
-                <a:spcPct val="132000"/>
+                <a:spcPct val="130000"/>
               </a:lnSpc>
               <a:spcAft>
                 <a:spcPts val="600"/>
@@ -5301,7 +5301,7 @@
             </a:r>
             <a:pPr indent="0" marL="0">
               <a:lnSpc>
-                <a:spcPct val="132000"/>
+                <a:spcPct val="130000"/>
               </a:lnSpc>
               <a:spcAft>
                 <a:spcPts val="600"/>
@@ -5319,7 +5319,7 @@
               </a:rPr>
               <a:t>Episode = pull. Value video = build. The collab price videos with SPOT, SITE or FLYER = act. One job per video, visible in the first line.</a:t>
             </a:r>
-            <a:endParaRPr lang="en-US" sz="1700" dirty="0"/>
+            <a:endParaRPr lang="en-US" sz="1600" dirty="0"/>
           </a:p>
         </p:txBody>
       </p:sp>
@@ -5331,8 +5331,8 @@
         </p:nvSpPr>
         <p:spPr>
           <a:xfrm>
-            <a:off x="4563533" y="2024380"/>
-            <a:ext cx="3064933" cy="4033520"/>
+            <a:off x="4563533" y="1940560"/>
+            <a:ext cx="3064933" cy="4206240"/>
           </a:xfrm>
           <a:prstGeom prst="rect">
             <a:avLst/>
@@ -5354,7 +5354,7 @@
               <a:buNone/>
             </a:pPr>
             <a:r>
-              <a:rPr lang="en-US" sz="1700" spc="-100" kern="0" dirty="0">
+              <a:rPr lang="en-US" sz="1600" spc="-100" kern="0" dirty="0">
                 <a:solidFill>
                   <a:srgbClr val="0F0F0F"/>
                 </a:solidFill>
@@ -5364,7 +5364,7 @@
               </a:rPr>
               <a:t>Document the pursuit</a:t>
             </a:r>
-            <a:endParaRPr lang="en-US" sz="1700" dirty="0"/>
+            <a:endParaRPr lang="en-US" sz="1600" dirty="0"/>
           </a:p>
           <a:p>
             <a:pPr indent="0" marL="0">
@@ -5377,7 +5377,7 @@
               <a:buNone/>
             </a:pPr>
             <a:r>
-              <a:rPr lang="en-US" sz="1200" dirty="0">
+              <a:rPr lang="en-US" sz="1150" dirty="0">
                 <a:solidFill>
                   <a:srgbClr val="6F6F6F"/>
                 </a:solidFill>
@@ -5387,12 +5387,12 @@
               </a:rPr>
               <a:t>“Stop creating, start documenting”</a:t>
             </a:r>
-            <a:endParaRPr lang="en-US" sz="1700" dirty="0"/>
+            <a:endParaRPr lang="en-US" sz="1600" dirty="0"/>
           </a:p>
           <a:p>
             <a:pPr indent="0" marL="0">
               <a:lnSpc>
-                <a:spcPct val="132000"/>
+                <a:spcPct val="130000"/>
               </a:lnSpc>
               <a:spcAft>
                 <a:spcPts val="1000"/>
@@ -5410,12 +5410,12 @@
               </a:rPr>
               <a:t>Documenting is not your routine, it is your pursuit: a goal strangers can root for. Progress is the storyline, so you never run out of content.</a:t>
             </a:r>
-            <a:endParaRPr lang="en-US" sz="1700" dirty="0"/>
+            <a:endParaRPr lang="en-US" sz="1600" dirty="0"/>
           </a:p>
           <a:p>
             <a:pPr indent="0" marL="0">
               <a:lnSpc>
-                <a:spcPct val="125000"/>
+                <a:spcPct val="122000"/>
               </a:lnSpc>
               <a:spcAft>
                 <a:spcPts val="1000"/>
@@ -5423,7 +5423,7 @@
               <a:buNone/>
             </a:pPr>
             <a:r>
-              <a:rPr lang="en-US" sz="1300" i="1" spc="-40" kern="0" dirty="0">
+              <a:rPr lang="en-US" sz="1250" i="1" spc="-40" kern="0" dirty="0">
                 <a:solidFill>
                   <a:srgbClr val="313336"/>
                 </a:solidFill>
@@ -5433,12 +5433,12 @@
               </a:rPr>
               <a:t>“Documenting isn’t about your daily routine. It’s about your pursuit. Your daily progress is the storyline.”</a:t>
             </a:r>
-            <a:endParaRPr lang="en-US" sz="1700" dirty="0"/>
+            <a:endParaRPr lang="en-US" sz="1600" dirty="0"/>
           </a:p>
           <a:p>
             <a:pPr indent="0" marL="0">
               <a:lnSpc>
-                <a:spcPct val="132000"/>
+                <a:spcPct val="130000"/>
               </a:lnSpc>
               <a:spcAft>
                 <a:spcPts val="600"/>
@@ -5458,7 +5458,7 @@
             </a:r>
             <a:pPr indent="0" marL="0">
               <a:lnSpc>
-                <a:spcPct val="132000"/>
+                <a:spcPct val="130000"/>
               </a:lnSpc>
               <a:spcAft>
                 <a:spcPts val="600"/>
@@ -5476,7 +5476,7 @@
               </a:rPr>
               <a:t>31 → 10K is the pursuit. The lesson opens every episode, the number proves it, the raw diary stays in Stories.</a:t>
             </a:r>
-            <a:endParaRPr lang="en-US" sz="1700" dirty="0"/>
+            <a:endParaRPr lang="en-US" sz="1600" dirty="0"/>
           </a:p>
         </p:txBody>
       </p:sp>
@@ -5488,8 +5488,8 @@
         </p:nvSpPr>
         <p:spPr>
           <a:xfrm>
-            <a:off x="8136467" y="2024380"/>
-            <a:ext cx="3064933" cy="4033520"/>
+            <a:off x="8136467" y="1940560"/>
+            <a:ext cx="3064933" cy="4206240"/>
           </a:xfrm>
           <a:prstGeom prst="rect">
             <a:avLst/>
@@ -5511,7 +5511,7 @@
               <a:buNone/>
             </a:pPr>
             <a:r>
-              <a:rPr lang="en-US" sz="1700" spc="-100" kern="0" dirty="0">
+              <a:rPr lang="en-US" sz="1600" spc="-100" kern="0" dirty="0">
                 <a:solidFill>
                   <a:srgbClr val="0F0F0F"/>
                 </a:solidFill>
@@ -5521,7 +5521,7 @@
               </a:rPr>
               <a:t>Four types that work when you start</a:t>
             </a:r>
-            <a:endParaRPr lang="en-US" sz="1700" dirty="0"/>
+            <a:endParaRPr lang="en-US" sz="1600" dirty="0"/>
           </a:p>
           <a:p>
             <a:pPr indent="0" marL="0">
@@ -5534,7 +5534,7 @@
               <a:buNone/>
             </a:pPr>
             <a:r>
-              <a:rPr lang="en-US" sz="1200" dirty="0">
+              <a:rPr lang="en-US" sz="1150" dirty="0">
                 <a:solidFill>
                   <a:srgbClr val="6F6F6F"/>
                 </a:solidFill>
@@ -5544,12 +5544,12 @@
               </a:rPr>
               <a:t>“Everything But the Edit” · a Canadian editing series</a:t>
             </a:r>
-            <a:endParaRPr lang="en-US" sz="1700" dirty="0"/>
+            <a:endParaRPr lang="en-US" sz="1600" dirty="0"/>
           </a:p>
           <a:p>
             <a:pPr indent="0" marL="0">
               <a:lnSpc>
-                <a:spcPct val="132000"/>
+                <a:spcPct val="130000"/>
               </a:lnSpc>
               <a:spcAft>
                 <a:spcPts val="1000"/>
@@ -5567,12 +5567,12 @@
               </a:rPr>
               <a:t>Curiosity (a window into a life that isn’t theirs), a series (people come back daily), bold contrast, and a remake of what already worked. You don’t need new ideas; notice what worked and do more of it.</a:t>
             </a:r>
-            <a:endParaRPr lang="en-US" sz="1700" dirty="0"/>
+            <a:endParaRPr lang="en-US" sz="1600" dirty="0"/>
           </a:p>
           <a:p>
             <a:pPr indent="0" marL="0">
               <a:lnSpc>
-                <a:spcPct val="125000"/>
+                <a:spcPct val="122000"/>
               </a:lnSpc>
               <a:spcAft>
                 <a:spcPts val="1000"/>
@@ -5580,7 +5580,7 @@
               <a:buNone/>
             </a:pPr>
             <a:r>
-              <a:rPr lang="en-US" sz="1300" i="1" spc="-40" kern="0" dirty="0">
+              <a:rPr lang="en-US" sz="1250" i="1" spc="-40" kern="0" dirty="0">
                 <a:solidFill>
                   <a:srgbClr val="313336"/>
                 </a:solidFill>
@@ -5590,12 +5590,12 @@
               </a:rPr>
               <a:t>“My Money video got over 70,000 views because people love a window into a life that isn’t theirs.”</a:t>
             </a:r>
-            <a:endParaRPr lang="en-US" sz="1700" dirty="0"/>
+            <a:endParaRPr lang="en-US" sz="1600" dirty="0"/>
           </a:p>
           <a:p>
             <a:pPr indent="0" marL="0">
               <a:lnSpc>
-                <a:spcPct val="132000"/>
+                <a:spcPct val="130000"/>
               </a:lnSpc>
               <a:spcAft>
                 <a:spcPts val="600"/>
@@ -5615,7 +5615,7 @@
             </a:r>
             <a:pPr indent="0" marL="0">
               <a:lnSpc>
-                <a:spcPct val="132000"/>
+                <a:spcPct val="130000"/>
               </a:lnSpc>
               <a:spcAft>
                 <a:spcPts val="600"/>
@@ -5633,7 +5633,7 @@
               </a:rPr>
               <a:t>Curiosity = the receipts videos. Series = 31 → 10K. Contrast = $560 job vs $419 order. Remake = your TikTok outliers, filmed again.</a:t>
             </a:r>
-            <a:endParaRPr lang="en-US" sz="1700" dirty="0"/>
+            <a:endParaRPr lang="en-US" sz="1600" dirty="0"/>
           </a:p>
         </p:txBody>
       </p:sp>
@@ -5756,7 +5756,7 @@
         <p:spPr>
           <a:xfrm>
             <a:off x="812800" y="1117600"/>
-            <a:ext cx="10566400" cy="589280"/>
+            <a:ext cx="10566400" cy="530860"/>
           </a:xfrm>
           <a:prstGeom prst="rect">
             <a:avLst/>
@@ -5775,7 +5775,7 @@
               <a:buNone/>
             </a:pPr>
             <a:r>
-              <a:rPr lang="en-US" sz="3600" spc="-216" kern="0" dirty="0">
+              <a:rPr lang="en-US" sz="3200" spc="-192" kern="0" dirty="0">
                 <a:solidFill>
                   <a:srgbClr val="0F0F0F"/>
                 </a:solidFill>
@@ -5792,7 +5792,7 @@
               <a:buNone/>
             </a:pPr>
             <a:r>
-              <a:rPr lang="en-US" sz="3600" i="1" spc="-216" kern="0" dirty="0">
+              <a:rPr lang="en-US" sz="3200" i="1" spc="-192" kern="0" dirty="0">
                 <a:solidFill>
                   <a:srgbClr val="FF0090"/>
                 </a:solidFill>
@@ -5809,7 +5809,7 @@
               <a:buNone/>
             </a:pPr>
             <a:r>
-              <a:rPr lang="en-US" sz="3600" spc="-216" kern="0" dirty="0">
+              <a:rPr lang="en-US" sz="3200" spc="-192" kern="0" dirty="0">
                 <a:solidFill>
                   <a:srgbClr val="0F0F0F"/>
                 </a:solidFill>
@@ -5819,7 +5819,7 @@
               </a:rPr>
               <a:t> moves</a:t>
             </a:r>
-            <a:endParaRPr lang="en-US" sz="3600" dirty="0"/>
+            <a:endParaRPr lang="en-US" sz="3200" dirty="0"/>
           </a:p>
         </p:txBody>
       </p:sp>
@@ -5831,8 +5831,8 @@
         </p:nvSpPr>
         <p:spPr>
           <a:xfrm>
-            <a:off x="812800" y="1859280"/>
-            <a:ext cx="3420533" cy="4363720"/>
+            <a:off x="812800" y="1788160"/>
+            <a:ext cx="3420533" cy="4511040"/>
           </a:xfrm>
           <a:prstGeom prst="roundRect">
             <a:avLst>
@@ -5865,8 +5865,8 @@
         </p:nvSpPr>
         <p:spPr>
           <a:xfrm>
-            <a:off x="4385733" y="1859280"/>
-            <a:ext cx="3420533" cy="4363720"/>
+            <a:off x="4385733" y="1788160"/>
+            <a:ext cx="3420533" cy="4511040"/>
           </a:xfrm>
           <a:prstGeom prst="roundRect">
             <a:avLst>
@@ -5899,8 +5899,8 @@
         </p:nvSpPr>
         <p:spPr>
           <a:xfrm>
-            <a:off x="7958667" y="1859280"/>
-            <a:ext cx="3420533" cy="4363720"/>
+            <a:off x="7958667" y="1788160"/>
+            <a:ext cx="3420533" cy="4511040"/>
           </a:xfrm>
           <a:prstGeom prst="roundRect">
             <a:avLst>
@@ -5933,8 +5933,8 @@
         </p:nvSpPr>
         <p:spPr>
           <a:xfrm>
-            <a:off x="990600" y="2024380"/>
-            <a:ext cx="3064933" cy="4033520"/>
+            <a:off x="990600" y="1940560"/>
+            <a:ext cx="3064933" cy="4206240"/>
           </a:xfrm>
           <a:prstGeom prst="rect">
             <a:avLst/>
@@ -5956,7 +5956,7 @@
               <a:buNone/>
             </a:pPr>
             <a:r>
-              <a:rPr lang="en-US" sz="1700" spc="-100" kern="0" dirty="0">
+              <a:rPr lang="en-US" sz="1600" spc="-100" kern="0" dirty="0">
                 <a:solidFill>
                   <a:srgbClr val="0F0F0F"/>
                 </a:solidFill>
@@ -5966,7 +5966,7 @@
               </a:rPr>
               <a:t>The urgency rant</a:t>
             </a:r>
-            <a:endParaRPr lang="en-US" sz="1700" dirty="0"/>
+            <a:endParaRPr lang="en-US" sz="1600" dirty="0"/>
           </a:p>
           <a:p>
             <a:pPr indent="0" marL="0">
@@ -5979,7 +5979,7 @@
               <a:buNone/>
             </a:pPr>
             <a:r>
-              <a:rPr lang="en-US" sz="1200" dirty="0">
+              <a:rPr lang="en-US" sz="1150" dirty="0">
                 <a:solidFill>
                   <a:srgbClr val="6F6F6F"/>
                 </a:solidFill>
@@ -5989,12 +5989,12 @@
               </a:rPr>
               <a:t>“There is a slow epidemic”</a:t>
             </a:r>
-            <a:endParaRPr lang="en-US" sz="1700" dirty="0"/>
+            <a:endParaRPr lang="en-US" sz="1600" dirty="0"/>
           </a:p>
           <a:p>
             <a:pPr indent="0" marL="0">
               <a:lnSpc>
-                <a:spcPct val="132000"/>
+                <a:spcPct val="130000"/>
               </a:lnSpc>
               <a:spcAft>
                 <a:spcPts val="1000"/>
@@ -6012,12 +6012,12 @@
               </a:rPr>
               <a:t>Name the condition, then the contrast: everyone wants the money, the body, the PR, and nobody moves. A run of short questions, no softening, one line the viewer repeats to a friend.</a:t>
             </a:r>
-            <a:endParaRPr lang="en-US" sz="1700" dirty="0"/>
+            <a:endParaRPr lang="en-US" sz="1600" dirty="0"/>
           </a:p>
           <a:p>
             <a:pPr indent="0" marL="0">
               <a:lnSpc>
-                <a:spcPct val="125000"/>
+                <a:spcPct val="122000"/>
               </a:lnSpc>
               <a:spcAft>
                 <a:spcPts val="1000"/>
@@ -6025,7 +6025,7 @@
               <a:buNone/>
             </a:pPr>
             <a:r>
-              <a:rPr lang="en-US" sz="1300" i="1" spc="-40" kern="0" dirty="0">
+              <a:rPr lang="en-US" sz="1250" i="1" spc="-40" kern="0" dirty="0">
                 <a:solidFill>
                   <a:srgbClr val="313336"/>
                 </a:solidFill>
@@ -6035,12 +6035,12 @@
               </a:rPr>
               <a:t>“Why is it taking you nine months to think about a name? You have nothing to lose.”</a:t>
             </a:r>
-            <a:endParaRPr lang="en-US" sz="1700" dirty="0"/>
+            <a:endParaRPr lang="en-US" sz="1600" dirty="0"/>
           </a:p>
           <a:p>
             <a:pPr indent="0" marL="0">
               <a:lnSpc>
-                <a:spcPct val="132000"/>
+                <a:spcPct val="130000"/>
               </a:lnSpc>
               <a:spcAft>
                 <a:spcPts val="600"/>
@@ -6060,7 +6060,7 @@
             </a:r>
             <a:pPr indent="0" marL="0">
               <a:lnSpc>
-                <a:spcPct val="132000"/>
+                <a:spcPct val="130000"/>
               </a:lnSpc>
               <a:spcAft>
                 <a:spcPts val="600"/>
@@ -6078,7 +6078,7 @@
               </a:rPr>
               <a:t>“You’ve had the idea for nine months. I started this account at 31 followers last week.” Strong topic: TikTok first, French hook on screen.</a:t>
             </a:r>
-            <a:endParaRPr lang="en-US" sz="1700" dirty="0"/>
+            <a:endParaRPr lang="en-US" sz="1600" dirty="0"/>
           </a:p>
         </p:txBody>
       </p:sp>
@@ -6090,8 +6090,8 @@
         </p:nvSpPr>
         <p:spPr>
           <a:xfrm>
-            <a:off x="4563533" y="2024380"/>
-            <a:ext cx="3064933" cy="4033520"/>
+            <a:off x="4563533" y="1940560"/>
+            <a:ext cx="3064933" cy="4206240"/>
           </a:xfrm>
           <a:prstGeom prst="rect">
             <a:avLst/>
@@ -6113,7 +6113,7 @@
               <a:buNone/>
             </a:pPr>
             <a:r>
-              <a:rPr lang="en-US" sz="1700" spc="-100" kern="0" dirty="0">
+              <a:rPr lang="en-US" sz="1600" spc="-100" kern="0" dirty="0">
                 <a:solidFill>
                   <a:srgbClr val="0F0F0F"/>
                 </a:solidFill>
@@ -6123,7 +6123,7 @@
               </a:rPr>
               <a:t>The question everyone asks</a:t>
             </a:r>
-            <a:endParaRPr lang="en-US" sz="1700" dirty="0"/>
+            <a:endParaRPr lang="en-US" sz="1600" dirty="0"/>
           </a:p>
           <a:p>
             <a:pPr indent="0" marL="0">
@@ -6136,7 +6136,7 @@
               <a:buNone/>
             </a:pPr>
             <a:r>
-              <a:rPr lang="en-US" sz="1200" dirty="0">
+              <a:rPr lang="en-US" sz="1150" dirty="0">
                 <a:solidFill>
                   <a:srgbClr val="6F6F6F"/>
                 </a:solidFill>
@@ -6146,12 +6146,12 @@
               </a:rPr>
               <a:t>“Where should I start?”</a:t>
             </a:r>
-            <a:endParaRPr lang="en-US" sz="1700" dirty="0"/>
+            <a:endParaRPr lang="en-US" sz="1600" dirty="0"/>
           </a:p>
           <a:p>
             <a:pPr indent="0" marL="0">
               <a:lnSpc>
-                <a:spcPct val="132000"/>
+                <a:spcPct val="130000"/>
               </a:lnSpc>
               <a:spcAft>
                 <a:spcPts val="1000"/>
@@ -6169,12 +6169,12 @@
               </a:rPr>
               <a:t>Open on the question, then the uncomfortable stat behind it. The answer is consistency, imperfection, the cringe and people one step ahead of you. Never gear.</a:t>
             </a:r>
-            <a:endParaRPr lang="en-US" sz="1700" dirty="0"/>
+            <a:endParaRPr lang="en-US" sz="1600" dirty="0"/>
           </a:p>
           <a:p>
             <a:pPr indent="0" marL="0">
               <a:lnSpc>
-                <a:spcPct val="125000"/>
+                <a:spcPct val="122000"/>
               </a:lnSpc>
               <a:spcAft>
                 <a:spcPts val="1000"/>
@@ -6182,7 +6182,7 @@
               <a:buNone/>
             </a:pPr>
             <a:r>
-              <a:rPr lang="en-US" sz="1300" i="1" spc="-40" kern="0" dirty="0">
+              <a:rPr lang="en-US" sz="1250" i="1" spc="-40" kern="0" dirty="0">
                 <a:solidFill>
                   <a:srgbClr val="313336"/>
                 </a:solidFill>
@@ -6192,12 +6192,12 @@
               </a:rPr>
               <a:t>“Everyone who asked me that has never posted more than five videos.”</a:t>
             </a:r>
-            <a:endParaRPr lang="en-US" sz="1700" dirty="0"/>
+            <a:endParaRPr lang="en-US" sz="1600" dirty="0"/>
           </a:p>
           <a:p>
             <a:pPr indent="0" marL="0">
               <a:lnSpc>
-                <a:spcPct val="132000"/>
+                <a:spcPct val="130000"/>
               </a:lnSpc>
               <a:spcAft>
                 <a:spcPts val="600"/>
@@ -6217,7 +6217,7 @@
             </a:r>
             <a:pPr indent="0" marL="0">
               <a:lnSpc>
-                <a:spcPct val="132000"/>
+                <a:spcPct val="130000"/>
               </a:lnSpc>
               <a:spcAft>
                 <a:spcPts val="600"/>
@@ -6235,7 +6235,7 @@
               </a:rPr>
               <a:t>“How do I get clients?” Everyone who asks me that has sent zero DMs. Here are the five I send a day. Reply-video format.</a:t>
             </a:r>
-            <a:endParaRPr lang="en-US" sz="1700" dirty="0"/>
+            <a:endParaRPr lang="en-US" sz="1600" dirty="0"/>
           </a:p>
         </p:txBody>
       </p:sp>
@@ -6247,8 +6247,8 @@
         </p:nvSpPr>
         <p:spPr>
           <a:xfrm>
-            <a:off x="8136467" y="2024380"/>
-            <a:ext cx="3064933" cy="4033520"/>
+            <a:off x="8136467" y="1940560"/>
+            <a:ext cx="3064933" cy="4206240"/>
           </a:xfrm>
           <a:prstGeom prst="rect">
             <a:avLst/>
@@ -6270,7 +6270,7 @@
               <a:buNone/>
             </a:pPr>
             <a:r>
-              <a:rPr lang="en-US" sz="1700" spc="-100" kern="0" dirty="0">
+              <a:rPr lang="en-US" sz="1600" spc="-100" kern="0" dirty="0">
                 <a:solidFill>
                   <a:srgbClr val="0F0F0F"/>
                 </a:solidFill>
@@ -6280,7 +6280,7 @@
               </a:rPr>
               <a:t>Say what others won’t, then outcare</a:t>
             </a:r>
-            <a:endParaRPr lang="en-US" sz="1700" dirty="0"/>
+            <a:endParaRPr lang="en-US" sz="1600" dirty="0"/>
           </a:p>
           <a:p>
             <a:pPr indent="0" marL="0">
@@ -6293,7 +6293,7 @@
               <a:buNone/>
             </a:pPr>
             <a:r>
-              <a:rPr lang="en-US" sz="1200" dirty="0">
+              <a:rPr lang="en-US" sz="1150" dirty="0">
                 <a:solidFill>
                   <a:srgbClr val="6F6F6F"/>
                 </a:solidFill>
@@ -6303,12 +6303,12 @@
               </a:rPr>
               <a:t>“My entire content strategy in 60 seconds”</a:t>
             </a:r>
-            <a:endParaRPr lang="en-US" sz="1700" dirty="0"/>
+            <a:endParaRPr lang="en-US" sz="1600" dirty="0"/>
           </a:p>
           <a:p>
             <a:pPr indent="0" marL="0">
               <a:lnSpc>
-                <a:spcPct val="132000"/>
+                <a:spcPct val="130000"/>
               </a:lnSpc>
               <a:spcAft>
                 <a:spcPts val="1000"/>
@@ -6326,12 +6326,12 @@
               </a:rPr>
               <a:t>Describe what the viewer feels better than they can. Say the thing people think but won’t. Don’t gatekeep, invite the follow, open loops across videos, repost your outliers every 90 days.</a:t>
             </a:r>
-            <a:endParaRPr lang="en-US" sz="1700" dirty="0"/>
+            <a:endParaRPr lang="en-US" sz="1600" dirty="0"/>
           </a:p>
           <a:p>
             <a:pPr indent="0" marL="0">
               <a:lnSpc>
-                <a:spcPct val="125000"/>
+                <a:spcPct val="122000"/>
               </a:lnSpc>
               <a:spcAft>
                 <a:spcPts val="1000"/>
@@ -6339,7 +6339,7 @@
               <a:buNone/>
             </a:pPr>
             <a:r>
-              <a:rPr lang="en-US" sz="1300" i="1" spc="-40" kern="0" dirty="0">
+              <a:rPr lang="en-US" sz="1250" i="1" spc="-40" kern="0" dirty="0">
                 <a:solidFill>
                   <a:srgbClr val="313336"/>
                 </a:solidFill>
@@ -6349,12 +6349,12 @@
               </a:rPr>
               <a:t>“I make six figures with mid-tier engagement. A lot of you have more engagement than me. What’s the difference?”</a:t>
             </a:r>
-            <a:endParaRPr lang="en-US" sz="1700" dirty="0"/>
+            <a:endParaRPr lang="en-US" sz="1600" dirty="0"/>
           </a:p>
           <a:p>
             <a:pPr indent="0" marL="0">
               <a:lnSpc>
-                <a:spcPct val="132000"/>
+                <a:spcPct val="130000"/>
               </a:lnSpc>
               <a:spcAft>
                 <a:spcPts val="600"/>
@@ -6374,7 +6374,7 @@
             </a:r>
             <a:pPr indent="0" marL="0">
               <a:lnSpc>
-                <a:spcPct val="132000"/>
+                <a:spcPct val="130000"/>
               </a:lnSpc>
               <a:spcAft>
                 <a:spcPts val="600"/>
@@ -6392,7 +6392,7 @@
               </a:rPr>
               <a:t>“4 million views paid me $0. One order paid $419. Here’s the difference.” Every episode ends on an open loop for the next one.</a:t>
             </a:r>
-            <a:endParaRPr lang="en-US" sz="1700" dirty="0"/>
+            <a:endParaRPr lang="en-US" sz="1600" dirty="0"/>
           </a:p>
         </p:txBody>
       </p:sp>
@@ -34009,7 +34009,7 @@
         <p:spPr>
           <a:xfrm>
             <a:off x="812800" y="1117600"/>
-            <a:ext cx="10566400" cy="589280"/>
+            <a:ext cx="10566400" cy="530860"/>
           </a:xfrm>
           <a:prstGeom prst="rect">
             <a:avLst/>
@@ -34028,7 +34028,7 @@
               <a:buNone/>
             </a:pPr>
             <a:r>
-              <a:rPr lang="en-US" sz="3600" spc="-216" kern="0" dirty="0">
+              <a:rPr lang="en-US" sz="3200" spc="-192" kern="0" dirty="0">
                 <a:solidFill>
                   <a:srgbClr val="0F0F0F"/>
                 </a:solidFill>
@@ -34045,7 +34045,7 @@
               <a:buNone/>
             </a:pPr>
             <a:r>
-              <a:rPr lang="en-US" sz="3600" i="1" spc="-216" kern="0" dirty="0">
+              <a:rPr lang="en-US" sz="3200" i="1" spc="-192" kern="0" dirty="0">
                 <a:solidFill>
                   <a:srgbClr val="FF0090"/>
                 </a:solidFill>
@@ -34062,7 +34062,7 @@
               <a:buNone/>
             </a:pPr>
             <a:r>
-              <a:rPr lang="en-US" sz="3600" spc="-216" kern="0" dirty="0">
+              <a:rPr lang="en-US" sz="3200" spc="-192" kern="0" dirty="0">
                 <a:solidFill>
                   <a:srgbClr val="0F0F0F"/>
                 </a:solidFill>
@@ -34072,7 +34072,7 @@
               </a:rPr>
               <a:t>, not the words</a:t>
             </a:r>
-            <a:endParaRPr lang="en-US" sz="3600" dirty="0"/>
+            <a:endParaRPr lang="en-US" sz="3200" dirty="0"/>
           </a:p>
         </p:txBody>
       </p:sp>
@@ -34084,8 +34084,8 @@
         </p:nvSpPr>
         <p:spPr>
           <a:xfrm>
-            <a:off x="812800" y="1859280"/>
-            <a:ext cx="3420533" cy="4363720"/>
+            <a:off x="812800" y="1788160"/>
+            <a:ext cx="3420533" cy="4511040"/>
           </a:xfrm>
           <a:prstGeom prst="roundRect">
             <a:avLst>
@@ -34118,8 +34118,8 @@
         </p:nvSpPr>
         <p:spPr>
           <a:xfrm>
-            <a:off x="4385733" y="1859280"/>
-            <a:ext cx="3420533" cy="4363720"/>
+            <a:off x="4385733" y="1788160"/>
+            <a:ext cx="3420533" cy="4511040"/>
           </a:xfrm>
           <a:prstGeom prst="roundRect">
             <a:avLst>
@@ -34152,8 +34152,8 @@
         </p:nvSpPr>
         <p:spPr>
           <a:xfrm>
-            <a:off x="7958667" y="1859280"/>
-            <a:ext cx="3420533" cy="4363720"/>
+            <a:off x="7958667" y="1788160"/>
+            <a:ext cx="3420533" cy="4511040"/>
           </a:xfrm>
           <a:prstGeom prst="roundRect">
             <a:avLst>
@@ -34186,8 +34186,8 @@
         </p:nvSpPr>
         <p:spPr>
           <a:xfrm>
-            <a:off x="990600" y="2024380"/>
-            <a:ext cx="3064933" cy="4033520"/>
+            <a:off x="990600" y="1940560"/>
+            <a:ext cx="3064933" cy="4206240"/>
           </a:xfrm>
           <a:prstGeom prst="rect">
             <a:avLst/>
@@ -34209,7 +34209,7 @@
               <a:buNone/>
             </a:pPr>
             <a:r>
-              <a:rPr lang="en-US" sz="1700" spc="-100" kern="0" dirty="0">
+              <a:rPr lang="en-US" sz="1600" spc="-100" kern="0" dirty="0">
                 <a:solidFill>
                   <a:srgbClr val="0F0F0F"/>
                 </a:solidFill>
@@ -34219,7 +34219,7 @@
               </a:rPr>
               <a:t>Jenny Hoyos</a:t>
             </a:r>
-            <a:endParaRPr lang="en-US" sz="1700" dirty="0"/>
+            <a:endParaRPr lang="en-US" sz="1600" dirty="0"/>
           </a:p>
           <a:p>
             <a:pPr indent="0" marL="0">
@@ -34232,7 +34232,7 @@
               <a:buNone/>
             </a:pPr>
             <a:r>
-              <a:rPr lang="en-US" sz="1200" dirty="0">
+              <a:rPr lang="en-US" sz="1150" dirty="0">
                 <a:solidFill>
                   <a:srgbClr val="6F6F6F"/>
                 </a:solidFill>
@@ -34242,12 +34242,12 @@
               </a:rPr>
               <a:t>YouTube Shorts · 600M+ views in a year</a:t>
             </a:r>
-            <a:endParaRPr lang="en-US" sz="1700" dirty="0"/>
+            <a:endParaRPr lang="en-US" sz="1600" dirty="0"/>
           </a:p>
           <a:p>
             <a:pPr indent="0" marL="0">
               <a:lnSpc>
-                <a:spcPct val="132000"/>
+                <a:spcPct val="130000"/>
               </a:lnSpc>
               <a:spcAft>
                 <a:spcPts val="1000"/>
@@ -34265,12 +34265,12 @@
               </a:rPr>
               <a:t>A stake, a number and someone to prove wrong in the first second. Shock, intrigue, satisfy: open the loop, then pay it off.</a:t>
             </a:r>
-            <a:endParaRPr lang="en-US" sz="1700" dirty="0"/>
+            <a:endParaRPr lang="en-US" sz="1600" dirty="0"/>
           </a:p>
           <a:p>
             <a:pPr indent="0" marL="0">
               <a:lnSpc>
-                <a:spcPct val="125000"/>
+                <a:spcPct val="122000"/>
               </a:lnSpc>
               <a:spcAft>
                 <a:spcPts val="1000"/>
@@ -34278,7 +34278,7 @@
               <a:buNone/>
             </a:pPr>
             <a:r>
-              <a:rPr lang="en-US" sz="1300" i="1" spc="-40" kern="0" dirty="0">
+              <a:rPr lang="en-US" sz="1250" i="1" spc="-40" kern="0" dirty="0">
                 <a:solidFill>
                   <a:srgbClr val="313336"/>
                 </a:solidFill>
@@ -34288,12 +34288,12 @@
               </a:rPr>
               <a:t>“What does $1 get you at Starbucks?” (23M views)</a:t>
             </a:r>
-            <a:endParaRPr lang="en-US" sz="1700" dirty="0"/>
+            <a:endParaRPr lang="en-US" sz="1600" dirty="0"/>
           </a:p>
           <a:p>
             <a:pPr indent="0" marL="0">
               <a:lnSpc>
-                <a:spcPct val="132000"/>
+                <a:spcPct val="130000"/>
               </a:lnSpc>
               <a:spcAft>
                 <a:spcPts val="600"/>
@@ -34313,7 +34313,7 @@
             </a:r>
             <a:pPr indent="0" marL="0">
               <a:lnSpc>
-                <a:spcPct val="132000"/>
+                <a:spcPct val="130000"/>
               </a:lnSpc>
               <a:spcAft>
                 <a:spcPts val="600"/>
@@ -34331,7 +34331,7 @@
               </a:rPr>
               <a:t>“What does $95 get you from a designer?”</a:t>
             </a:r>
-            <a:endParaRPr lang="en-US" sz="1700" dirty="0"/>
+            <a:endParaRPr lang="en-US" sz="1600" dirty="0"/>
           </a:p>
         </p:txBody>
       </p:sp>
@@ -34343,8 +34343,8 @@
         </p:nvSpPr>
         <p:spPr>
           <a:xfrm>
-            <a:off x="4563533" y="2024380"/>
-            <a:ext cx="3064933" cy="4033520"/>
+            <a:off x="4563533" y="1940560"/>
+            <a:ext cx="3064933" cy="4206240"/>
           </a:xfrm>
           <a:prstGeom prst="rect">
             <a:avLst/>
@@ -34366,7 +34366,7 @@
               <a:buNone/>
             </a:pPr>
             <a:r>
-              <a:rPr lang="en-US" sz="1700" spc="-100" kern="0" dirty="0">
+              <a:rPr lang="en-US" sz="1600" spc="-100" kern="0" dirty="0">
                 <a:solidFill>
                   <a:srgbClr val="0F0F0F"/>
                 </a:solidFill>
@@ -34376,7 +34376,7 @@
               </a:rPr>
               <a:t>Alex Hormozi</a:t>
             </a:r>
-            <a:endParaRPr lang="en-US" sz="1700" dirty="0"/>
+            <a:endParaRPr lang="en-US" sz="1600" dirty="0"/>
           </a:p>
           <a:p>
             <a:pPr indent="0" marL="0">
@@ -34389,7 +34389,7 @@
               <a:buNone/>
             </a:pPr>
             <a:r>
-              <a:rPr lang="en-US" sz="1200" dirty="0">
+              <a:rPr lang="en-US" sz="1150" dirty="0">
                 <a:solidFill>
                   <a:srgbClr val="6F6F6F"/>
                 </a:solidFill>
@@ -34399,12 +34399,12 @@
               </a:rPr>
               <a:t>Business short-form</a:t>
             </a:r>
-            <a:endParaRPr lang="en-US" sz="1700" dirty="0"/>
+            <a:endParaRPr lang="en-US" sz="1600" dirty="0"/>
           </a:p>
           <a:p>
             <a:pPr indent="0" marL="0">
               <a:lnSpc>
-                <a:spcPct val="132000"/>
+                <a:spcPct val="130000"/>
               </a:lnSpc>
               <a:spcAft>
                 <a:spcPts val="1000"/>
@@ -34422,12 +34422,12 @@
               </a:rPr>
               <a:t>“How I”, never “how to”. A bold claim or a confession with a number in the first half-second.</a:t>
             </a:r>
-            <a:endParaRPr lang="en-US" sz="1700" dirty="0"/>
+            <a:endParaRPr lang="en-US" sz="1600" dirty="0"/>
           </a:p>
           <a:p>
             <a:pPr indent="0" marL="0">
               <a:lnSpc>
-                <a:spcPct val="125000"/>
+                <a:spcPct val="122000"/>
               </a:lnSpc>
               <a:spcAft>
                 <a:spcPts val="1000"/>
@@ -34435,7 +34435,7 @@
               <a:buNone/>
             </a:pPr>
             <a:r>
-              <a:rPr lang="en-US" sz="1300" i="1" spc="-40" kern="0" dirty="0">
+              <a:rPr lang="en-US" sz="1250" i="1" spc="-40" kern="0" dirty="0">
                 <a:solidFill>
                   <a:srgbClr val="313336"/>
                 </a:solidFill>
@@ -34445,12 +34445,12 @@
               </a:rPr>
               <a:t>“I paid Grant Cardone $120,000 for four hours.”</a:t>
             </a:r>
-            <a:endParaRPr lang="en-US" sz="1700" dirty="0"/>
+            <a:endParaRPr lang="en-US" sz="1600" dirty="0"/>
           </a:p>
           <a:p>
             <a:pPr indent="0" marL="0">
               <a:lnSpc>
-                <a:spcPct val="132000"/>
+                <a:spcPct val="130000"/>
               </a:lnSpc>
               <a:spcAft>
                 <a:spcPts val="600"/>
@@ -34470,7 +34470,7 @@
             </a:r>
             <a:pPr indent="0" marL="0">
               <a:lnSpc>
-                <a:spcPct val="132000"/>
+                <a:spcPct val="130000"/>
               </a:lnSpc>
               <a:spcAft>
                 <a:spcPts val="600"/>
@@ -34488,7 +34488,7 @@
               </a:rPr>
               <a:t>“I charge $1,500 for a website and I’m a student. Here’s why clients pay it.”</a:t>
             </a:r>
-            <a:endParaRPr lang="en-US" sz="1700" dirty="0"/>
+            <a:endParaRPr lang="en-US" sz="1600" dirty="0"/>
           </a:p>
         </p:txBody>
       </p:sp>
@@ -34500,8 +34500,8 @@
         </p:nvSpPr>
         <p:spPr>
           <a:xfrm>
-            <a:off x="8136467" y="2024380"/>
-            <a:ext cx="3064933" cy="4033520"/>
+            <a:off x="8136467" y="1940560"/>
+            <a:ext cx="3064933" cy="4206240"/>
           </a:xfrm>
           <a:prstGeom prst="rect">
             <a:avLst/>
@@ -34523,7 +34523,7 @@
               <a:buNone/>
             </a:pPr>
             <a:r>
-              <a:rPr lang="en-US" sz="1700" spc="-100" kern="0" dirty="0">
+              <a:rPr lang="en-US" sz="1600" spc="-100" kern="0" dirty="0">
                 <a:solidFill>
                   <a:srgbClr val="0F0F0F"/>
                 </a:solidFill>
@@ -34533,7 +34533,7 @@
               </a:rPr>
               <a:t>Dan Koe</a:t>
             </a:r>
-            <a:endParaRPr lang="en-US" sz="1700" dirty="0"/>
+            <a:endParaRPr lang="en-US" sz="1600" dirty="0"/>
           </a:p>
           <a:p>
             <a:pPr indent="0" marL="0">
@@ -34546,7 +34546,7 @@
               <a:buNone/>
             </a:pPr>
             <a:r>
-              <a:rPr lang="en-US" sz="1200" dirty="0">
+              <a:rPr lang="en-US" sz="1150" dirty="0">
                 <a:solidFill>
                   <a:srgbClr val="6F6F6F"/>
                 </a:solidFill>
@@ -34556,12 +34556,12 @@
               </a:rPr>
               <a:t>2.6M across platforms</a:t>
             </a:r>
-            <a:endParaRPr lang="en-US" sz="1700" dirty="0"/>
+            <a:endParaRPr lang="en-US" sz="1600" dirty="0"/>
           </a:p>
           <a:p>
             <a:pPr indent="0" marL="0">
               <a:lnSpc>
-                <a:spcPct val="132000"/>
+                <a:spcPct val="130000"/>
               </a:lnSpc>
               <a:spcAft>
                 <a:spcPts val="1000"/>
@@ -34579,12 +34579,12 @@
               </a:rPr>
               <a:t>Aphorism first: a belief stated as fact, then stop. Or the “you” diagnosis that names the viewer’s condition.</a:t>
             </a:r>
-            <a:endParaRPr lang="en-US" sz="1700" dirty="0"/>
+            <a:endParaRPr lang="en-US" sz="1600" dirty="0"/>
           </a:p>
           <a:p>
             <a:pPr indent="0" marL="0">
               <a:lnSpc>
-                <a:spcPct val="125000"/>
+                <a:spcPct val="122000"/>
               </a:lnSpc>
               <a:spcAft>
                 <a:spcPts val="1000"/>
@@ -34592,7 +34592,7 @@
               <a:buNone/>
             </a:pPr>
             <a:r>
-              <a:rPr lang="en-US" sz="1300" i="1" spc="-40" kern="0" dirty="0">
+              <a:rPr lang="en-US" sz="1250" i="1" spc="-40" kern="0" dirty="0">
                 <a:solidFill>
                   <a:srgbClr val="313336"/>
                 </a:solidFill>
@@ -34602,12 +34602,12 @@
               </a:rPr>
               <a:t>“Nobody is coming to save you.”</a:t>
             </a:r>
-            <a:endParaRPr lang="en-US" sz="1700" dirty="0"/>
+            <a:endParaRPr lang="en-US" sz="1600" dirty="0"/>
           </a:p>
           <a:p>
             <a:pPr indent="0" marL="0">
               <a:lnSpc>
-                <a:spcPct val="132000"/>
+                <a:spcPct val="130000"/>
               </a:lnSpc>
               <a:spcAft>
                 <a:spcPts val="600"/>
@@ -34627,7 +34627,7 @@
             </a:r>
             <a:pPr indent="0" marL="0">
               <a:lnSpc>
-                <a:spcPct val="132000"/>
+                <a:spcPct val="130000"/>
               </a:lnSpc>
               <a:spcAft>
                 <a:spcPts val="600"/>
@@ -34645,7 +34645,7 @@
               </a:rPr>
               <a:t>“Nobody is going to DM you first.”</a:t>
             </a:r>
-            <a:endParaRPr lang="en-US" sz="1700" dirty="0"/>
+            <a:endParaRPr lang="en-US" sz="1600" dirty="0"/>
           </a:p>
         </p:txBody>
       </p:sp>
@@ -34768,7 +34768,7 @@
         <p:spPr>
           <a:xfrm>
             <a:off x="812800" y="1117600"/>
-            <a:ext cx="10566400" cy="589280"/>
+            <a:ext cx="10566400" cy="530860"/>
           </a:xfrm>
           <a:prstGeom prst="rect">
             <a:avLst/>
@@ -34787,7 +34787,7 @@
               <a:buNone/>
             </a:pPr>
             <a:r>
-              <a:rPr lang="en-US" sz="3600" spc="-216" kern="0" dirty="0">
+              <a:rPr lang="en-US" sz="3200" spc="-192" kern="0" dirty="0">
                 <a:solidFill>
                   <a:srgbClr val="0F0F0F"/>
                 </a:solidFill>
@@ -34804,7 +34804,7 @@
               <a:buNone/>
             </a:pPr>
             <a:r>
-              <a:rPr lang="en-US" sz="3600" i="1" spc="-216" kern="0" dirty="0">
+              <a:rPr lang="en-US" sz="3200" i="1" spc="-192" kern="0" dirty="0">
                 <a:solidFill>
                   <a:srgbClr val="FF0090"/>
                 </a:solidFill>
@@ -34821,7 +34821,7 @@
               <a:buNone/>
             </a:pPr>
             <a:r>
-              <a:rPr lang="en-US" sz="3600" spc="-216" kern="0" dirty="0">
+              <a:rPr lang="en-US" sz="3200" spc="-192" kern="0" dirty="0">
                 <a:solidFill>
                   <a:srgbClr val="0F0F0F"/>
                 </a:solidFill>
@@ -34831,7 +34831,7 @@
               </a:rPr>
               <a:t> moves</a:t>
             </a:r>
-            <a:endParaRPr lang="en-US" sz="3600" dirty="0"/>
+            <a:endParaRPr lang="en-US" sz="3200" dirty="0"/>
           </a:p>
         </p:txBody>
       </p:sp>
@@ -34843,8 +34843,8 @@
         </p:nvSpPr>
         <p:spPr>
           <a:xfrm>
-            <a:off x="812800" y="1859280"/>
-            <a:ext cx="3420533" cy="4363720"/>
+            <a:off x="812800" y="1788160"/>
+            <a:ext cx="3420533" cy="4511040"/>
           </a:xfrm>
           <a:prstGeom prst="roundRect">
             <a:avLst>
@@ -34877,8 +34877,8 @@
         </p:nvSpPr>
         <p:spPr>
           <a:xfrm>
-            <a:off x="4385733" y="1859280"/>
-            <a:ext cx="3420533" cy="4363720"/>
+            <a:off x="4385733" y="1788160"/>
+            <a:ext cx="3420533" cy="4511040"/>
           </a:xfrm>
           <a:prstGeom prst="roundRect">
             <a:avLst>
@@ -34911,8 +34911,8 @@
         </p:nvSpPr>
         <p:spPr>
           <a:xfrm>
-            <a:off x="7958667" y="1859280"/>
-            <a:ext cx="3420533" cy="4363720"/>
+            <a:off x="7958667" y="1788160"/>
+            <a:ext cx="3420533" cy="4511040"/>
           </a:xfrm>
           <a:prstGeom prst="roundRect">
             <a:avLst>
@@ -34945,8 +34945,8 @@
         </p:nvSpPr>
         <p:spPr>
           <a:xfrm>
-            <a:off x="990600" y="2024380"/>
-            <a:ext cx="3064933" cy="4033520"/>
+            <a:off x="990600" y="1940560"/>
+            <a:ext cx="3064933" cy="4206240"/>
           </a:xfrm>
           <a:prstGeom prst="rect">
             <a:avLst/>
@@ -34968,7 +34968,7 @@
               <a:buNone/>
             </a:pPr>
             <a:r>
-              <a:rPr lang="en-US" sz="1700" spc="-100" kern="0" dirty="0">
+              <a:rPr lang="en-US" sz="1600" spc="-100" kern="0" dirty="0">
                 <a:solidFill>
                   <a:srgbClr val="0F0F0F"/>
                 </a:solidFill>
@@ -34978,7 +34978,7 @@
               </a:rPr>
               <a:t>Ali Abdaal</a:t>
             </a:r>
-            <a:endParaRPr lang="en-US" sz="1700" dirty="0"/>
+            <a:endParaRPr lang="en-US" sz="1600" dirty="0"/>
           </a:p>
           <a:p>
             <a:pPr indent="0" marL="0">
@@ -34991,7 +34991,7 @@
               <a:buNone/>
             </a:pPr>
             <a:r>
-              <a:rPr lang="en-US" sz="1200" dirty="0">
+              <a:rPr lang="en-US" sz="1150" dirty="0">
                 <a:solidFill>
                   <a:srgbClr val="6F6F6F"/>
                 </a:solidFill>
@@ -35001,12 +35001,12 @@
               </a:rPr>
               <a:t>1M+ on YouTube</a:t>
             </a:r>
-            <a:endParaRPr lang="en-US" sz="1700" dirty="0"/>
+            <a:endParaRPr lang="en-US" sz="1600" dirty="0"/>
           </a:p>
           <a:p>
             <a:pPr indent="0" marL="0">
               <a:lnSpc>
-                <a:spcPct val="132000"/>
+                <a:spcPct val="130000"/>
               </a:lnSpc>
               <a:spcAft>
                 <a:spcPts val="1000"/>
@@ -35024,12 +35024,12 @@
               </a:rPr>
               <a:t>A second-person pain question from frame 1, the promise at 3 seconds, the concept named at 5. Same move as the under-10K qualifier: “If you have under 1,000 followers, watch this.”</a:t>
             </a:r>
-            <a:endParaRPr lang="en-US" sz="1700" dirty="0"/>
+            <a:endParaRPr lang="en-US" sz="1600" dirty="0"/>
           </a:p>
           <a:p>
             <a:pPr indent="0" marL="0">
               <a:lnSpc>
-                <a:spcPct val="125000"/>
+                <a:spcPct val="122000"/>
               </a:lnSpc>
               <a:spcAft>
                 <a:spcPts val="1000"/>
@@ -35037,7 +35037,7 @@
               <a:buNone/>
             </a:pPr>
             <a:r>
-              <a:rPr lang="en-US" sz="1300" i="1" spc="-40" kern="0" dirty="0">
+              <a:rPr lang="en-US" sz="1250" i="1" spc="-40" kern="0" dirty="0">
                 <a:solidFill>
                   <a:srgbClr val="313336"/>
                 </a:solidFill>
@@ -35047,12 +35047,12 @@
               </a:rPr>
               <a:t>“Have you ever heard of the region beta paradox? You might be suffering from it right now.”</a:t>
             </a:r>
-            <a:endParaRPr lang="en-US" sz="1700" dirty="0"/>
+            <a:endParaRPr lang="en-US" sz="1600" dirty="0"/>
           </a:p>
           <a:p>
             <a:pPr indent="0" marL="0">
               <a:lnSpc>
-                <a:spcPct val="132000"/>
+                <a:spcPct val="130000"/>
               </a:lnSpc>
               <a:spcAft>
                 <a:spcPts val="600"/>
@@ -35072,7 +35072,7 @@
             </a:r>
             <a:pPr indent="0" marL="0">
               <a:lnSpc>
-                <a:spcPct val="132000"/>
+                <a:spcPct val="130000"/>
               </a:lnSpc>
               <a:spcAft>
                 <a:spcPts val="600"/>
@@ -35090,7 +35090,7 @@
               </a:rPr>
               <a:t>“You don’t need 10K followers to get PR packages. You need one page.”</a:t>
             </a:r>
-            <a:endParaRPr lang="en-US" sz="1700" dirty="0"/>
+            <a:endParaRPr lang="en-US" sz="1600" dirty="0"/>
           </a:p>
         </p:txBody>
       </p:sp>
@@ -35102,8 +35102,8 @@
         </p:nvSpPr>
         <p:spPr>
           <a:xfrm>
-            <a:off x="4563533" y="2024380"/>
-            <a:ext cx="3064933" cy="4033520"/>
+            <a:off x="4563533" y="1940560"/>
+            <a:ext cx="3064933" cy="4206240"/>
           </a:xfrm>
           <a:prstGeom prst="rect">
             <a:avLst/>
@@ -35125,7 +35125,7 @@
               <a:buNone/>
             </a:pPr>
             <a:r>
-              <a:rPr lang="en-US" sz="1700" spc="-100" kern="0" dirty="0">
+              <a:rPr lang="en-US" sz="1600" spc="-100" kern="0" dirty="0">
                 <a:solidFill>
                   <a:srgbClr val="0F0F0F"/>
                 </a:solidFill>
@@ -35135,7 +35135,7 @@
               </a:rPr>
               <a:t>Tanner Leatherstein</a:t>
             </a:r>
-            <a:endParaRPr lang="en-US" sz="1700" dirty="0"/>
+            <a:endParaRPr lang="en-US" sz="1600" dirty="0"/>
           </a:p>
           <a:p>
             <a:pPr indent="0" marL="0">
@@ -35148,7 +35148,7 @@
               <a:buNone/>
             </a:pPr>
             <a:r>
-              <a:rPr lang="en-US" sz="1200" dirty="0">
+              <a:rPr lang="en-US" sz="1150" dirty="0">
                 <a:solidFill>
                   <a:srgbClr val="6F6F6F"/>
                 </a:solidFill>
@@ -35158,12 +35158,12 @@
               </a:rPr>
               <a:t>1.7M · a Hook Point case</a:t>
             </a:r>
-            <a:endParaRPr lang="en-US" sz="1700" dirty="0"/>
+            <a:endParaRPr lang="en-US" sz="1600" dirty="0"/>
           </a:p>
           <a:p>
             <a:pPr indent="0" marL="0">
               <a:lnSpc>
-                <a:spcPct val="132000"/>
+                <a:spcPct val="130000"/>
               </a:lnSpc>
               <a:spcAft>
                 <a:spcPts val="1000"/>
@@ -35181,12 +35181,12 @@
               </a:rPr>
               <a:t>Cut the product open and show what it really costs. The reveal is the hook.</a:t>
             </a:r>
-            <a:endParaRPr lang="en-US" sz="1700" dirty="0"/>
+            <a:endParaRPr lang="en-US" sz="1600" dirty="0"/>
           </a:p>
           <a:p>
             <a:pPr indent="0" marL="0">
               <a:lnSpc>
-                <a:spcPct val="125000"/>
+                <a:spcPct val="122000"/>
               </a:lnSpc>
               <a:spcAft>
                 <a:spcPts val="1000"/>
@@ -35194,7 +35194,7 @@
               <a:buNone/>
             </a:pPr>
             <a:r>
-              <a:rPr lang="en-US" sz="1300" i="1" spc="-40" kern="0" dirty="0">
+              <a:rPr lang="en-US" sz="1250" i="1" spc="-40" kern="0" dirty="0">
                 <a:solidFill>
                   <a:srgbClr val="313336"/>
                 </a:solidFill>
@@ -35204,12 +35204,12 @@
               </a:rPr>
               <a:t>Cuts luxury bags apart on camera to show what they cost to make.</a:t>
             </a:r>
-            <a:endParaRPr lang="en-US" sz="1700" dirty="0"/>
+            <a:endParaRPr lang="en-US" sz="1600" dirty="0"/>
           </a:p>
           <a:p>
             <a:pPr indent="0" marL="0">
               <a:lnSpc>
-                <a:spcPct val="132000"/>
+                <a:spcPct val="130000"/>
               </a:lnSpc>
               <a:spcAft>
                 <a:spcPts val="600"/>
@@ -35229,7 +35229,7 @@
             </a:r>
             <a:pPr indent="0" marL="0">
               <a:lnSpc>
-                <a:spcPct val="132000"/>
+                <a:spcPct val="130000"/>
               </a:lnSpc>
               <a:spcAft>
                 <a:spcPts val="600"/>
@@ -35247,7 +35247,7 @@
               </a:rPr>
               <a:t>“This flyer is $95. Here’s what it actually takes.”</a:t>
             </a:r>
-            <a:endParaRPr lang="en-US" sz="1700" dirty="0"/>
+            <a:endParaRPr lang="en-US" sz="1600" dirty="0"/>
           </a:p>
         </p:txBody>
       </p:sp>
@@ -35259,8 +35259,8 @@
         </p:nvSpPr>
         <p:spPr>
           <a:xfrm>
-            <a:off x="8136467" y="2024380"/>
-            <a:ext cx="3064933" cy="4033520"/>
+            <a:off x="8136467" y="1940560"/>
+            <a:ext cx="3064933" cy="4206240"/>
           </a:xfrm>
           <a:prstGeom prst="rect">
             <a:avLst/>
@@ -35282,7 +35282,7 @@
               <a:buNone/>
             </a:pPr>
             <a:r>
-              <a:rPr lang="en-US" sz="1700" spc="-100" kern="0" dirty="0">
+              <a:rPr lang="en-US" sz="1600" spc="-100" kern="0" dirty="0">
                 <a:solidFill>
                   <a:srgbClr val="0F0F0F"/>
                 </a:solidFill>
@@ -35292,7 +35292,7 @@
               </a:rPr>
               <a:t>Two characters, one lightbulb</a:t>
             </a:r>
-            <a:endParaRPr lang="en-US" sz="1700" dirty="0"/>
+            <a:endParaRPr lang="en-US" sz="1600" dirty="0"/>
           </a:p>
           <a:p>
             <a:pPr indent="0" marL="0">
@@ -35305,7 +35305,7 @@
               <a:buNone/>
             </a:pPr>
             <a:r>
-              <a:rPr lang="en-US" sz="1200" dirty="0">
+              <a:rPr lang="en-US" sz="1150" dirty="0">
                 <a:solidFill>
                   <a:srgbClr val="6F6F6F"/>
                 </a:solidFill>
@@ -35315,12 +35315,12 @@
               </a:rPr>
               <a:t>A Hook Point format</a:t>
             </a:r>
-            <a:endParaRPr lang="en-US" sz="1700" dirty="0"/>
+            <a:endParaRPr lang="en-US" sz="1600" dirty="0"/>
           </a:p>
           <a:p>
             <a:pPr indent="0" marL="0">
               <a:lnSpc>
-                <a:spcPct val="132000"/>
+                <a:spcPct val="130000"/>
               </a:lnSpc>
               <a:spcAft>
                 <a:spcPts val="1000"/>
@@ -35338,12 +35338,12 @@
               </a:rPr>
               <a:t>Play the client and the designer. The expert corrects the novice’s misconception, and the viewer has the lightbulb.</a:t>
             </a:r>
-            <a:endParaRPr lang="en-US" sz="1700" dirty="0"/>
+            <a:endParaRPr lang="en-US" sz="1600" dirty="0"/>
           </a:p>
           <a:p>
             <a:pPr indent="0" marL="0">
               <a:lnSpc>
-                <a:spcPct val="125000"/>
+                <a:spcPct val="122000"/>
               </a:lnSpc>
               <a:spcAft>
                 <a:spcPts val="1000"/>
@@ -35351,7 +35351,7 @@
               <a:buNone/>
             </a:pPr>
             <a:r>
-              <a:rPr lang="en-US" sz="1300" i="1" spc="-40" kern="0" dirty="0">
+              <a:rPr lang="en-US" sz="1250" i="1" spc="-40" kern="0" dirty="0">
                 <a:solidFill>
                   <a:srgbClr val="313336"/>
                 </a:solidFill>
@@ -35361,12 +35361,12 @@
               </a:rPr>
               <a:t>Expert and novice in one video, two outfits, hard cuts.</a:t>
             </a:r>
-            <a:endParaRPr lang="en-US" sz="1700" dirty="0"/>
+            <a:endParaRPr lang="en-US" sz="1600" dirty="0"/>
           </a:p>
           <a:p>
             <a:pPr indent="0" marL="0">
               <a:lnSpc>
-                <a:spcPct val="132000"/>
+                <a:spcPct val="130000"/>
               </a:lnSpc>
               <a:spcAft>
                 <a:spcPts val="600"/>
@@ -35386,7 +35386,7 @@
             </a:r>
             <a:pPr indent="0" marL="0">
               <a:lnSpc>
-                <a:spcPct val="132000"/>
+                <a:spcPct val="130000"/>
               </a:lnSpc>
               <a:spcAft>
                 <a:spcPts val="600"/>
@@ -35404,7 +35404,7 @@
               </a:rPr>
               <a:t>“Can you do it for exposure?” / “No. Here’s what I’ll do instead.”</a:t>
             </a:r>
-            <a:endParaRPr lang="en-US" sz="1700" dirty="0"/>
+            <a:endParaRPr lang="en-US" sz="1600" dirty="0"/>
           </a:p>
         </p:txBody>
       </p:sp>
@@ -35527,7 +35527,7 @@
         <p:spPr>
           <a:xfrm>
             <a:off x="812800" y="1117600"/>
-            <a:ext cx="10566400" cy="589280"/>
+            <a:ext cx="10566400" cy="530860"/>
           </a:xfrm>
           <a:prstGeom prst="rect">
             <a:avLst/>
@@ -35546,7 +35546,7 @@
               <a:buNone/>
             </a:pPr>
             <a:r>
-              <a:rPr lang="en-US" sz="3600" spc="-216" kern="0" dirty="0">
+              <a:rPr lang="en-US" sz="3200" spc="-192" kern="0" dirty="0">
                 <a:solidFill>
                   <a:srgbClr val="0F0F0F"/>
                 </a:solidFill>
@@ -35563,7 +35563,7 @@
               <a:buNone/>
             </a:pPr>
             <a:r>
-              <a:rPr lang="en-US" sz="3600" i="1" spc="-216" kern="0" dirty="0">
+              <a:rPr lang="en-US" sz="3200" i="1" spc="-192" kern="0" dirty="0">
                 <a:solidFill>
                   <a:srgbClr val="FF0090"/>
                 </a:solidFill>
@@ -35580,7 +35580,7 @@
               <a:buNone/>
             </a:pPr>
             <a:r>
-              <a:rPr lang="en-US" sz="3600" spc="-216" kern="0" dirty="0">
+              <a:rPr lang="en-US" sz="3200" spc="-192" kern="0" dirty="0">
                 <a:solidFill>
                   <a:srgbClr val="0F0F0F"/>
                 </a:solidFill>
@@ -35590,7 +35590,7 @@
               </a:rPr>
               <a:t> knows</a:t>
             </a:r>
-            <a:endParaRPr lang="en-US" sz="3600" dirty="0"/>
+            <a:endParaRPr lang="en-US" sz="3200" dirty="0"/>
           </a:p>
         </p:txBody>
       </p:sp>
@@ -35602,8 +35602,8 @@
         </p:nvSpPr>
         <p:spPr>
           <a:xfrm>
-            <a:off x="812800" y="1859280"/>
-            <a:ext cx="3420533" cy="4363720"/>
+            <a:off x="812800" y="1788160"/>
+            <a:ext cx="3420533" cy="4511040"/>
           </a:xfrm>
           <a:prstGeom prst="roundRect">
             <a:avLst>
@@ -35636,8 +35636,8 @@
         </p:nvSpPr>
         <p:spPr>
           <a:xfrm>
-            <a:off x="4385733" y="1859280"/>
-            <a:ext cx="3420533" cy="4363720"/>
+            <a:off x="4385733" y="1788160"/>
+            <a:ext cx="3420533" cy="4511040"/>
           </a:xfrm>
           <a:prstGeom prst="roundRect">
             <a:avLst>
@@ -35670,8 +35670,8 @@
         </p:nvSpPr>
         <p:spPr>
           <a:xfrm>
-            <a:off x="7958667" y="1859280"/>
-            <a:ext cx="3420533" cy="4363720"/>
+            <a:off x="7958667" y="1788160"/>
+            <a:ext cx="3420533" cy="4511040"/>
           </a:xfrm>
           <a:prstGeom prst="roundRect">
             <a:avLst>
@@ -35704,8 +35704,8 @@
         </p:nvSpPr>
         <p:spPr>
           <a:xfrm>
-            <a:off x="990600" y="2024380"/>
-            <a:ext cx="3064933" cy="4033520"/>
+            <a:off x="990600" y="1940560"/>
+            <a:ext cx="3064933" cy="4206240"/>
           </a:xfrm>
           <a:prstGeom prst="rect">
             <a:avLst/>
@@ -35727,7 +35727,7 @@
               <a:buNone/>
             </a:pPr>
             <a:r>
-              <a:rPr lang="en-US" sz="1700" spc="-100" kern="0" dirty="0">
+              <a:rPr lang="en-US" sz="1600" spc="-100" kern="0" dirty="0">
                 <a:solidFill>
                   <a:srgbClr val="0F0F0F"/>
                 </a:solidFill>
@@ -35737,7 +35737,7 @@
               </a:rPr>
               <a:t>Charity Ekezie</a:t>
             </a:r>
-            <a:endParaRPr lang="en-US" sz="1700" dirty="0"/>
+            <a:endParaRPr lang="en-US" sz="1600" dirty="0"/>
           </a:p>
           <a:p>
             <a:pPr indent="0" marL="0">
@@ -35750,7 +35750,7 @@
               <a:buNone/>
             </a:pPr>
             <a:r>
-              <a:rPr lang="en-US" sz="1200" dirty="0">
+              <a:rPr lang="en-US" sz="1150" dirty="0">
                 <a:solidFill>
                   <a:srgbClr val="6F6F6F"/>
                 </a:solidFill>
@@ -35760,12 +35760,12 @@
               </a:rPr>
               <a:t>Nigeria · a 17M-view video</a:t>
             </a:r>
-            <a:endParaRPr lang="en-US" sz="1700" dirty="0"/>
+            <a:endParaRPr lang="en-US" sz="1600" dirty="0"/>
           </a:p>
           <a:p>
             <a:pPr indent="0" marL="0">
               <a:lnSpc>
-                <a:spcPct val="132000"/>
+                <a:spcPct val="130000"/>
               </a:lnSpc>
               <a:spcAft>
                 <a:spcPts val="1000"/>
@@ -35783,12 +35783,12 @@
               </a:rPr>
               <a:t>Reply to a real comment as the hook. The viewer becomes the protagonist. Sarcasm when the comment deserves it.</a:t>
             </a:r>
-            <a:endParaRPr lang="en-US" sz="1700" dirty="0"/>
+            <a:endParaRPr lang="en-US" sz="1600" dirty="0"/>
           </a:p>
           <a:p>
             <a:pPr indent="0" marL="0">
               <a:lnSpc>
-                <a:spcPct val="125000"/>
+                <a:spcPct val="122000"/>
               </a:lnSpc>
               <a:spcAft>
                 <a:spcPts val="1000"/>
@@ -35796,7 +35796,7 @@
               <a:buNone/>
             </a:pPr>
             <a:r>
-              <a:rPr lang="en-US" sz="1300" i="1" spc="-40" kern="0" dirty="0">
+              <a:rPr lang="en-US" sz="1250" i="1" spc="-40" kern="0" dirty="0">
                 <a:solidFill>
                   <a:srgbClr val="313336"/>
                 </a:solidFill>
@@ -35806,12 +35806,12 @@
               </a:rPr>
               <a:t>Her videos open on the ignorant comment, then she answers it.</a:t>
             </a:r>
-            <a:endParaRPr lang="en-US" sz="1700" dirty="0"/>
+            <a:endParaRPr lang="en-US" sz="1600" dirty="0"/>
           </a:p>
           <a:p>
             <a:pPr indent="0" marL="0">
               <a:lnSpc>
-                <a:spcPct val="132000"/>
+                <a:spcPct val="130000"/>
               </a:lnSpc>
               <a:spcAft>
                 <a:spcPts val="600"/>
@@ -35831,7 +35831,7 @@
             </a:r>
             <a:pPr indent="0" marL="0">
               <a:lnSpc>
-                <a:spcPct val="132000"/>
+                <a:spcPct val="130000"/>
               </a:lnSpc>
               <a:spcAft>
                 <a:spcPts val="600"/>
@@ -35849,7 +35849,7 @@
               </a:rPr>
               <a:t>Every “how?” comment this week becomes a reply video.</a:t>
             </a:r>
-            <a:endParaRPr lang="en-US" sz="1700" dirty="0"/>
+            <a:endParaRPr lang="en-US" sz="1600" dirty="0"/>
           </a:p>
         </p:txBody>
       </p:sp>
@@ -35861,8 +35861,8 @@
         </p:nvSpPr>
         <p:spPr>
           <a:xfrm>
-            <a:off x="4563533" y="2024380"/>
-            <a:ext cx="3064933" cy="4033520"/>
+            <a:off x="4563533" y="1940560"/>
+            <a:ext cx="3064933" cy="4206240"/>
           </a:xfrm>
           <a:prstGeom prst="rect">
             <a:avLst/>
@@ -35884,7 +35884,7 @@
               <a:buNone/>
             </a:pPr>
             <a:r>
-              <a:rPr lang="en-US" sz="1700" spc="-100" kern="0" dirty="0">
+              <a:rPr lang="en-US" sz="1600" spc="-100" kern="0" dirty="0">
                 <a:solidFill>
                   <a:srgbClr val="0F0F0F"/>
                 </a:solidFill>
@@ -35894,7 +35894,7 @@
               </a:rPr>
               <a:t>Jade Beason</a:t>
             </a:r>
-            <a:endParaRPr lang="en-US" sz="1700" dirty="0"/>
+            <a:endParaRPr lang="en-US" sz="1600" dirty="0"/>
           </a:p>
           <a:p>
             <a:pPr indent="0" marL="0">
@@ -35907,7 +35907,7 @@
               <a:buNone/>
             </a:pPr>
             <a:r>
-              <a:rPr lang="en-US" sz="1200" dirty="0">
+              <a:rPr lang="en-US" sz="1150" dirty="0">
                 <a:solidFill>
                   <a:srgbClr val="6F6F6F"/>
                 </a:solidFill>
@@ -35917,12 +35917,12 @@
               </a:rPr>
               <a:t>UK creator-business</a:t>
             </a:r>
-            <a:endParaRPr lang="en-US" sz="1700" dirty="0"/>
+            <a:endParaRPr lang="en-US" sz="1600" dirty="0"/>
           </a:p>
           <a:p>
             <a:pPr indent="0" marL="0">
               <a:lnSpc>
-                <a:spcPct val="132000"/>
+                <a:spcPct val="130000"/>
               </a:lnSpc>
               <a:spcAft>
                 <a:spcPts val="1000"/>
@@ -35940,12 +35940,12 @@
               </a:rPr>
               <a:t>Series are the growth engine of a creator business. Name the series on screen every time.</a:t>
             </a:r>
-            <a:endParaRPr lang="en-US" sz="1700" dirty="0"/>
+            <a:endParaRPr lang="en-US" sz="1600" dirty="0"/>
           </a:p>
           <a:p>
             <a:pPr indent="0" marL="0">
               <a:lnSpc>
-                <a:spcPct val="125000"/>
+                <a:spcPct val="122000"/>
               </a:lnSpc>
               <a:spcAft>
                 <a:spcPts val="1000"/>
@@ -35953,7 +35953,7 @@
               <a:buNone/>
             </a:pPr>
             <a:r>
-              <a:rPr lang="en-US" sz="1300" i="1" spc="-40" kern="0" dirty="0">
+              <a:rPr lang="en-US" sz="1250" i="1" spc="-40" kern="0" dirty="0">
                 <a:solidFill>
                   <a:srgbClr val="313336"/>
                 </a:solidFill>
@@ -35963,12 +35963,12 @@
               </a:rPr>
               <a:t>Her 2026 framework puts series content first.</a:t>
             </a:r>
-            <a:endParaRPr lang="en-US" sz="1700" dirty="0"/>
+            <a:endParaRPr lang="en-US" sz="1600" dirty="0"/>
           </a:p>
           <a:p>
             <a:pPr indent="0" marL="0">
               <a:lnSpc>
-                <a:spcPct val="132000"/>
+                <a:spcPct val="130000"/>
               </a:lnSpc>
               <a:spcAft>
                 <a:spcPts val="600"/>
@@ -35988,7 +35988,7 @@
             </a:r>
             <a:pPr indent="0" marL="0">
               <a:lnSpc>
-                <a:spcPct val="132000"/>
+                <a:spcPct val="130000"/>
               </a:lnSpc>
               <a:spcAft>
                 <a:spcPts val="600"/>
@@ -36006,7 +36006,7 @@
               </a:rPr>
               <a:t>“31 → 10K, day 2” on every episode, same place, same style.</a:t>
             </a:r>
-            <a:endParaRPr lang="en-US" sz="1700" dirty="0"/>
+            <a:endParaRPr lang="en-US" sz="1600" dirty="0"/>
           </a:p>
         </p:txBody>
       </p:sp>
@@ -36018,8 +36018,8 @@
         </p:nvSpPr>
         <p:spPr>
           <a:xfrm>
-            <a:off x="8136467" y="2024380"/>
-            <a:ext cx="3064933" cy="4033520"/>
+            <a:off x="8136467" y="1940560"/>
+            <a:ext cx="3064933" cy="4206240"/>
           </a:xfrm>
           <a:prstGeom prst="rect">
             <a:avLst/>
@@ -36041,7 +36041,7 @@
               <a:buNone/>
             </a:pPr>
             <a:r>
-              <a:rPr lang="en-US" sz="1700" spc="-100" kern="0" dirty="0">
+              <a:rPr lang="en-US" sz="1600" spc="-100" kern="0" dirty="0">
                 <a:solidFill>
                   <a:srgbClr val="0F0F0F"/>
                 </a:solidFill>
@@ -36051,7 +36051,7 @@
               </a:rPr>
               <a:t>Kone Mia, Gaelle Taglao, Rach Makosso</a:t>
             </a:r>
-            <a:endParaRPr lang="en-US" sz="1700" dirty="0"/>
+            <a:endParaRPr lang="en-US" sz="1600" dirty="0"/>
           </a:p>
           <a:p>
             <a:pPr indent="0" marL="0">
@@ -36064,7 +36064,7 @@
               <a:buNone/>
             </a:pPr>
             <a:r>
-              <a:rPr lang="en-US" sz="1200" dirty="0">
+              <a:rPr lang="en-US" sz="1150" dirty="0">
                 <a:solidFill>
                   <a:srgbClr val="6F6F6F"/>
                 </a:solidFill>
@@ -36074,12 +36074,12 @@
               </a:rPr>
               <a:t>Côte d’Ivoire TikTok · 1.5M, 827K, and the franc-parler</a:t>
             </a:r>
-            <a:endParaRPr lang="en-US" sz="1700" dirty="0"/>
+            <a:endParaRPr lang="en-US" sz="1600" dirty="0"/>
           </a:p>
           <a:p>
             <a:pPr indent="0" marL="0">
               <a:lnSpc>
-                <a:spcPct val="132000"/>
+                <a:spcPct val="130000"/>
               </a:lnSpc>
               <a:spcAft>
                 <a:spcPts val="1000"/>
@@ -36097,12 +36097,12 @@
               </a:rPr>
               <a:t>Straight talk to camera, humour, social commentary. In 2026 Ivorian creators have pushed public bodies to respond.</a:t>
             </a:r>
-            <a:endParaRPr lang="en-US" sz="1700" dirty="0"/>
+            <a:endParaRPr lang="en-US" sz="1600" dirty="0"/>
           </a:p>
           <a:p>
             <a:pPr indent="0" marL="0">
               <a:lnSpc>
-                <a:spcPct val="125000"/>
+                <a:spcPct val="122000"/>
               </a:lnSpc>
               <a:spcAft>
                 <a:spcPts val="1000"/>
@@ -36110,7 +36110,7 @@
               <a:buNone/>
             </a:pPr>
             <a:r>
-              <a:rPr lang="en-US" sz="1300" i="1" spc="-40" kern="0" dirty="0">
+              <a:rPr lang="en-US" sz="1250" i="1" spc="-40" kern="0" dirty="0">
                 <a:solidFill>
                   <a:srgbClr val="313336"/>
                 </a:solidFill>
@@ -36120,12 +36120,12 @@
               </a:rPr>
               <a:t>What everyone is living, said out loud.</a:t>
             </a:r>
-            <a:endParaRPr lang="en-US" sz="1700" dirty="0"/>
+            <a:endParaRPr lang="en-US" sz="1600" dirty="0"/>
           </a:p>
           <a:p>
             <a:pPr indent="0" marL="0">
               <a:lnSpc>
-                <a:spcPct val="132000"/>
+                <a:spcPct val="130000"/>
               </a:lnSpc>
               <a:spcAft>
                 <a:spcPts val="600"/>
@@ -36145,7 +36145,7 @@
             </a:r>
             <a:pPr indent="0" marL="0">
               <a:lnSpc>
-                <a:spcPct val="132000"/>
+                <a:spcPct val="130000"/>
               </a:lnSpc>
               <a:spcAft>
                 <a:spcPts val="600"/>
@@ -36163,7 +36163,7 @@
               </a:rPr>
               <a:t>Your petition and call-out videos on @keekyt. Keep the humour in.</a:t>
             </a:r>
-            <a:endParaRPr lang="en-US" sz="1700" dirty="0"/>
+            <a:endParaRPr lang="en-US" sz="1600" dirty="0"/>
           </a:p>
         </p:txBody>
       </p:sp>

</xml_diff>